<commit_message>
Syllabus and 1st day refinements
</commit_message>
<xml_diff>
--- a/slides/0112-Introduction.pptx
+++ b/slides/0112-Introduction.pptx
@@ -2215,7 +2215,7 @@
           <a:p>
             <a:fld id="{5BCAD085-E8A6-8845-BD4E-CB4CCA059FC4}" type="datetimeFigureOut">
               <a:rPr lang="en-US" smtClean="0"/>
-              <a:t>1/6/26</a:t>
+              <a:t>1/7/26</a:t>
             </a:fld>
             <a:endParaRPr lang="en-US"/>
           </a:p>
@@ -2474,7 +2474,7 @@
           <a:p>
             <a:fld id="{A7F72289-EB8A-47CA-A283-A769C9E761BF}" type="datetime1">
               <a:rPr lang="en-US" smtClean="0"/>
-              <a:t>1/6/26</a:t>
+              <a:t>1/7/26</a:t>
             </a:fld>
             <a:endParaRPr lang="en-US" dirty="0"/>
           </a:p>
@@ -2805,7 +2805,7 @@
           <a:p>
             <a:fld id="{3CC8FB4D-92F2-4C28-8BFC-2AE0229C3E9A}" type="datetime1">
               <a:rPr lang="en-US" smtClean="0"/>
-              <a:t>1/6/26</a:t>
+              <a:t>1/7/26</a:t>
             </a:fld>
             <a:endParaRPr lang="en-US"/>
           </a:p>
@@ -3079,7 +3079,7 @@
           <a:p>
             <a:fld id="{5BCAD085-E8A6-8845-BD4E-CB4CCA059FC4}" type="datetimeFigureOut">
               <a:rPr lang="en-US" smtClean="0"/>
-              <a:t>1/6/26</a:t>
+              <a:t>1/7/26</a:t>
             </a:fld>
             <a:endParaRPr lang="en-US"/>
           </a:p>
@@ -4268,7 +4268,7 @@
           </a:ln>
           <a:extLst>
             <a:ext uri="{C572A759-6A51-4108-AA02-DFA0A04FC94B}">
-              <ma14:wrappingTextBoxFlag xmlns="" xmlns:m="http://schemas.openxmlformats.org/officeDocument/2006/math" xmlns:a14="http://schemas.microsoft.com/office/drawing/2010/main" xmlns:ma14="http://schemas.microsoft.com/office/mac/drawingml/2011/main" val="1"/>
+              <ma14:wrappingTextBoxFlag xmlns:ma14="http://schemas.microsoft.com/office/mac/drawingml/2011/main" xmlns:a14="http://schemas.microsoft.com/office/drawing/2010/main" xmlns:m="http://schemas.openxmlformats.org/officeDocument/2006/math" xmlns="" val="1"/>
             </a:ext>
           </a:extLst>
         </p:spPr>
@@ -4307,7 +4307,7 @@
           </a:ln>
           <a:extLst>
             <a:ext uri="{C572A759-6A51-4108-AA02-DFA0A04FC94B}">
-              <ma14:wrappingTextBoxFlag xmlns="" xmlns:m="http://schemas.openxmlformats.org/officeDocument/2006/math" xmlns:a14="http://schemas.microsoft.com/office/drawing/2010/main" xmlns:ma14="http://schemas.microsoft.com/office/mac/drawingml/2011/main" val="1"/>
+              <ma14:wrappingTextBoxFlag xmlns:ma14="http://schemas.microsoft.com/office/mac/drawingml/2011/main" xmlns:a14="http://schemas.microsoft.com/office/drawing/2010/main" xmlns:m="http://schemas.openxmlformats.org/officeDocument/2006/math" xmlns="" val="1"/>
             </a:ext>
           </a:extLst>
         </p:spPr>
@@ -5233,7 +5233,7 @@
             <a:pPr lvl="1"/>
             <a:r>
               <a:rPr lang="en-US" dirty="0"/>
-              <a:t>Student (by next class)</a:t>
+              <a:t>Yourself (by 1/21)</a:t>
             </a:r>
           </a:p>
           <a:p>
@@ -5344,13 +5344,13 @@
           <a:p>
             <a:r>
               <a:rPr lang="en-US" dirty="0"/>
-              <a:t>Before the next class, fill out </a:t>
+              <a:t>Before class on 1/21, fill out this survey under </a:t>
             </a:r>
             <a:r>
               <a:rPr lang="en-US" dirty="0">
                 <a:hlinkClick r:id="rId2"/>
               </a:rPr>
-              <a:t>Meet Your Classmates</a:t>
+              <a:t>Participation</a:t>
             </a:r>
             <a:r>
               <a:rPr lang="en-US" dirty="0"/>
@@ -5414,7 +5414,7 @@
           </a:prstGeom>
           <a:extLst>
             <a:ext uri="{C572A759-6A51-4108-AA02-DFA0A04FC94B}">
-              <ma14:wrappingTextBoxFlag xmlns="" xmlns:m="http://schemas.openxmlformats.org/officeDocument/2006/math" xmlns:a14="http://schemas.microsoft.com/office/drawing/2010/main" xmlns:ma14="http://schemas.microsoft.com/office/mac/drawingml/2011/main" val="1"/>
+              <ma14:wrappingTextBoxFlag xmlns:ma14="http://schemas.microsoft.com/office/mac/drawingml/2011/main" xmlns:a14="http://schemas.microsoft.com/office/drawing/2010/main" xmlns:m="http://schemas.openxmlformats.org/officeDocument/2006/math" xmlns="" val="1"/>
             </a:ext>
           </a:extLst>
         </p:spPr>
@@ -9657,13 +9657,13 @@
           <a:p>
             <a:r>
               <a:rPr lang="en-US" dirty="0"/>
-              <a:t>By Wednesday 1/14 at 8:30am, fill out </a:t>
+              <a:t>By next Wednesday 1/21 at 8:30am, fill out the Introduce Yourself survey under </a:t>
             </a:r>
             <a:r>
               <a:rPr lang="en-US" dirty="0">
                 <a:hlinkClick r:id="rId4"/>
               </a:rPr>
-              <a:t>Meet Your Classmates</a:t>
+              <a:t>Participation</a:t>
             </a:r>
             <a:r>
               <a:rPr lang="en-US" dirty="0"/>
@@ -14730,7 +14730,7 @@
           </a:prstGeom>
           <a:extLst>
             <a:ext uri="{C572A759-6A51-4108-AA02-DFA0A04FC94B}">
-              <ma14:wrappingTextBoxFlag xmlns="" xmlns:m="http://schemas.openxmlformats.org/officeDocument/2006/math" xmlns:a14="http://schemas.microsoft.com/office/drawing/2010/main" xmlns:ma14="http://schemas.microsoft.com/office/mac/drawingml/2011/main" val="1"/>
+              <ma14:wrappingTextBoxFlag xmlns:ma14="http://schemas.microsoft.com/office/mac/drawingml/2011/main" xmlns:a14="http://schemas.microsoft.com/office/drawing/2010/main" xmlns:m="http://schemas.openxmlformats.org/officeDocument/2006/math" xmlns="" val="1"/>
             </a:ext>
           </a:extLst>
         </p:spPr>
@@ -14765,7 +14765,7 @@
           </a:ln>
           <a:extLst>
             <a:ext uri="{C572A759-6A51-4108-AA02-DFA0A04FC94B}">
-              <ma14:wrappingTextBoxFlag xmlns="" xmlns:m="http://schemas.openxmlformats.org/officeDocument/2006/math" xmlns:a14="http://schemas.microsoft.com/office/drawing/2010/main" xmlns:ma14="http://schemas.microsoft.com/office/mac/drawingml/2011/main" val="1"/>
+              <ma14:wrappingTextBoxFlag xmlns:ma14="http://schemas.microsoft.com/office/mac/drawingml/2011/main" xmlns:a14="http://schemas.microsoft.com/office/drawing/2010/main" xmlns:m="http://schemas.openxmlformats.org/officeDocument/2006/math" xmlns="" val="1"/>
             </a:ext>
           </a:extLst>
         </p:spPr>
@@ -15444,7 +15444,7 @@
           </a:prstGeom>
           <a:extLst>
             <a:ext uri="{C572A759-6A51-4108-AA02-DFA0A04FC94B}">
-              <ma14:wrappingTextBoxFlag xmlns="" xmlns:m="http://schemas.openxmlformats.org/officeDocument/2006/math" xmlns:a14="http://schemas.microsoft.com/office/drawing/2010/main" xmlns:ma14="http://schemas.microsoft.com/office/mac/drawingml/2011/main" val="1"/>
+              <ma14:wrappingTextBoxFlag xmlns:ma14="http://schemas.microsoft.com/office/mac/drawingml/2011/main" xmlns:a14="http://schemas.microsoft.com/office/drawing/2010/main" xmlns:m="http://schemas.openxmlformats.org/officeDocument/2006/math" xmlns="" val="1"/>
             </a:ext>
           </a:extLst>
         </p:spPr>

</xml_diff>

<commit_message>
Updating lecture slides and exercises through 1/21
</commit_message>
<xml_diff>
--- a/slides/0112-Introduction.pptx
+++ b/slides/0112-Introduction.pptx
@@ -2215,7 +2215,7 @@
           <a:p>
             <a:fld id="{5BCAD085-E8A6-8845-BD4E-CB4CCA059FC4}" type="datetimeFigureOut">
               <a:rPr lang="en-US" smtClean="0"/>
-              <a:t>1/7/26</a:t>
+              <a:t>1/13/26</a:t>
             </a:fld>
             <a:endParaRPr lang="en-US"/>
           </a:p>
@@ -2474,7 +2474,7 @@
           <a:p>
             <a:fld id="{A7F72289-EB8A-47CA-A283-A769C9E761BF}" type="datetime1">
               <a:rPr lang="en-US" smtClean="0"/>
-              <a:t>1/7/26</a:t>
+              <a:t>1/13/26</a:t>
             </a:fld>
             <a:endParaRPr lang="en-US" dirty="0"/>
           </a:p>
@@ -2805,7 +2805,7 @@
           <a:p>
             <a:fld id="{3CC8FB4D-92F2-4C28-8BFC-2AE0229C3E9A}" type="datetime1">
               <a:rPr lang="en-US" smtClean="0"/>
-              <a:t>1/7/26</a:t>
+              <a:t>1/13/26</a:t>
             </a:fld>
             <a:endParaRPr lang="en-US"/>
           </a:p>
@@ -3079,7 +3079,7 @@
           <a:p>
             <a:fld id="{5BCAD085-E8A6-8845-BD4E-CB4CCA059FC4}" type="datetimeFigureOut">
               <a:rPr lang="en-US" smtClean="0"/>
-              <a:t>1/7/26</a:t>
+              <a:t>1/13/26</a:t>
             </a:fld>
             <a:endParaRPr lang="en-US"/>
           </a:p>
@@ -4268,7 +4268,7 @@
           </a:ln>
           <a:extLst>
             <a:ext uri="{C572A759-6A51-4108-AA02-DFA0A04FC94B}">
-              <ma14:wrappingTextBoxFlag xmlns:ma14="http://schemas.microsoft.com/office/mac/drawingml/2011/main" xmlns:a14="http://schemas.microsoft.com/office/drawing/2010/main" xmlns:m="http://schemas.openxmlformats.org/officeDocument/2006/math" xmlns="" val="1"/>
+              <ma14:wrappingTextBoxFlag xmlns="" xmlns:m="http://schemas.openxmlformats.org/officeDocument/2006/math" xmlns:a14="http://schemas.microsoft.com/office/drawing/2010/main" xmlns:ma14="http://schemas.microsoft.com/office/mac/drawingml/2011/main" val="1"/>
             </a:ext>
           </a:extLst>
         </p:spPr>
@@ -4307,7 +4307,7 @@
           </a:ln>
           <a:extLst>
             <a:ext uri="{C572A759-6A51-4108-AA02-DFA0A04FC94B}">
-              <ma14:wrappingTextBoxFlag xmlns:ma14="http://schemas.microsoft.com/office/mac/drawingml/2011/main" xmlns:a14="http://schemas.microsoft.com/office/drawing/2010/main" xmlns:m="http://schemas.openxmlformats.org/officeDocument/2006/math" xmlns="" val="1"/>
+              <ma14:wrappingTextBoxFlag xmlns="" xmlns:m="http://schemas.openxmlformats.org/officeDocument/2006/math" xmlns:a14="http://schemas.microsoft.com/office/drawing/2010/main" xmlns:ma14="http://schemas.microsoft.com/office/mac/drawingml/2011/main" val="1"/>
             </a:ext>
           </a:extLst>
         </p:spPr>
@@ -5414,7 +5414,7 @@
           </a:prstGeom>
           <a:extLst>
             <a:ext uri="{C572A759-6A51-4108-AA02-DFA0A04FC94B}">
-              <ma14:wrappingTextBoxFlag xmlns:ma14="http://schemas.microsoft.com/office/mac/drawingml/2011/main" xmlns:a14="http://schemas.microsoft.com/office/drawing/2010/main" xmlns:m="http://schemas.openxmlformats.org/officeDocument/2006/math" xmlns="" val="1"/>
+              <ma14:wrappingTextBoxFlag xmlns="" xmlns:m="http://schemas.openxmlformats.org/officeDocument/2006/math" xmlns:a14="http://schemas.microsoft.com/office/drawing/2010/main" xmlns:ma14="http://schemas.microsoft.com/office/mac/drawingml/2011/main" val="1"/>
             </a:ext>
           </a:extLst>
         </p:spPr>
@@ -9657,7 +9657,19 @@
           <a:p>
             <a:r>
               <a:rPr lang="en-US" dirty="0"/>
-              <a:t>By next Wednesday 1/21 at 8:30am, fill out the Introduce Yourself survey under </a:t>
+              <a:t>By next Wednesday 1/21 </a:t>
+            </a:r>
+            <a:r>
+              <a:rPr lang="en-US"/>
+              <a:t>at 8:30am,</a:t>
+            </a:r>
+            <a:endParaRPr lang="en-US" dirty="0"/>
+          </a:p>
+          <a:p>
+            <a:pPr lvl="1"/>
+            <a:r>
+              <a:rPr lang="en-US" dirty="0"/>
+              <a:t>Fill out the Introduce Yourself survey under </a:t>
             </a:r>
             <a:r>
               <a:rPr lang="en-US" dirty="0">
@@ -9671,15 +9683,16 @@
             </a:r>
           </a:p>
           <a:p>
+            <a:pPr lvl="1"/>
             <a:r>
               <a:rPr lang="en-US" dirty="0"/>
-              <a:t>By next Wednesday 1/21 at 8:30am, complete Exercise 0.</a:t>
+              <a:t>Complete Exercise 0.</a:t>
             </a:r>
           </a:p>
           <a:p>
             <a:r>
               <a:rPr lang="en-US" dirty="0"/>
-              <a:t>By next Friday 1/21 at 8:30am, complete Exercise 1.</a:t>
+              <a:t>By next Friday 1/23 at 8:30am, complete Exercise 1.</a:t>
             </a:r>
           </a:p>
         </p:txBody>
@@ -14730,7 +14743,7 @@
           </a:prstGeom>
           <a:extLst>
             <a:ext uri="{C572A759-6A51-4108-AA02-DFA0A04FC94B}">
-              <ma14:wrappingTextBoxFlag xmlns:ma14="http://schemas.microsoft.com/office/mac/drawingml/2011/main" xmlns:a14="http://schemas.microsoft.com/office/drawing/2010/main" xmlns:m="http://schemas.openxmlformats.org/officeDocument/2006/math" xmlns="" val="1"/>
+              <ma14:wrappingTextBoxFlag xmlns="" xmlns:m="http://schemas.openxmlformats.org/officeDocument/2006/math" xmlns:a14="http://schemas.microsoft.com/office/drawing/2010/main" xmlns:ma14="http://schemas.microsoft.com/office/mac/drawingml/2011/main" val="1"/>
             </a:ext>
           </a:extLst>
         </p:spPr>
@@ -14765,7 +14778,7 @@
           </a:ln>
           <a:extLst>
             <a:ext uri="{C572A759-6A51-4108-AA02-DFA0A04FC94B}">
-              <ma14:wrappingTextBoxFlag xmlns:ma14="http://schemas.microsoft.com/office/mac/drawingml/2011/main" xmlns:a14="http://schemas.microsoft.com/office/drawing/2010/main" xmlns:m="http://schemas.openxmlformats.org/officeDocument/2006/math" xmlns="" val="1"/>
+              <ma14:wrappingTextBoxFlag xmlns="" xmlns:m="http://schemas.openxmlformats.org/officeDocument/2006/math" xmlns:a14="http://schemas.microsoft.com/office/drawing/2010/main" xmlns:ma14="http://schemas.microsoft.com/office/mac/drawingml/2011/main" val="1"/>
             </a:ext>
           </a:extLst>
         </p:spPr>
@@ -15444,7 +15457,7 @@
           </a:prstGeom>
           <a:extLst>
             <a:ext uri="{C572A759-6A51-4108-AA02-DFA0A04FC94B}">
-              <ma14:wrappingTextBoxFlag xmlns:ma14="http://schemas.microsoft.com/office/mac/drawingml/2011/main" xmlns:a14="http://schemas.microsoft.com/office/drawing/2010/main" xmlns:m="http://schemas.openxmlformats.org/officeDocument/2006/math" xmlns="" val="1"/>
+              <ma14:wrappingTextBoxFlag xmlns="" xmlns:m="http://schemas.openxmlformats.org/officeDocument/2006/math" xmlns:a14="http://schemas.microsoft.com/office/drawing/2010/main" xmlns:ma14="http://schemas.microsoft.com/office/mac/drawingml/2011/main" val="1"/>
             </a:ext>
           </a:extLst>
         </p:spPr>

</xml_diff>